<commit_message>
Add Citrini image asset, extend grading sweep to Stages 4-5
- Further_Study_Resources.pptx: add Citrini research image
- sweep_stage.py: support --stage 4 and 5 in the post-deadline sweep
- settings.local.json: allow WebFetch from citriniresearch.com
</commit_message>
<xml_diff>
--- a/docs/presentations/Further_Study_Resources.pptx
+++ b/docs/presentations/Further_Study_Resources.pptx
@@ -18,6 +18,7 @@
     <p:sldId id="262" r:id="rId9"/>
     <p:sldId id="264" r:id="rId10"/>
     <p:sldId id="263" r:id="rId11"/>
+    <p:sldId id="270" r:id="rId17"/>
   </p:sldIdLst>
   <p:sldSz cx="12192000" cy="6858000"/>
   <p:notesSz cx="6858000" cy="12192000"/>
@@ -2873,7 +2874,869 @@
                 <a:ea typeface="Open Sans" pitchFamily="34" charset="-122"/>
                 <a:cs typeface="Open Sans" pitchFamily="34" charset="-120"/>
               </a:rPr>
-              <a:t>7 / 8</a:t>
+              <a:t>7 / 9</a:t>
+            </a:r>
+            <a:endParaRPr lang="en-US" sz="1000" dirty="0"/>
+          </a:p>
+        </p:txBody>
+      </p:sp>
+    </p:spTree>
+  </p:cSld>
+  <p:clrMapOvr>
+    <a:masterClrMapping/>
+  </p:clrMapOvr>
+</p:sld>
+</file>
+
+<file path=ppt/slides/slide11.xml><?xml version="1.0" encoding="utf-8"?>
+<p:sld xmlns:a="http://schemas.openxmlformats.org/drawingml/2006/main" xmlns:r="http://schemas.openxmlformats.org/officeDocument/2006/relationships" xmlns:p="http://schemas.openxmlformats.org/presentationml/2006/main">
+  <p:cSld name="Slide 3">
+    <p:bg>
+      <p:bgPr>
+        <a:solidFill>
+          <a:srgbClr val="FFFFFF"/>
+        </a:solidFill>
+        <a:effectLst/>
+      </p:bgPr>
+    </p:bg>
+    <p:spTree>
+      <p:nvGrpSpPr>
+        <p:cNvPr id="1" name=""/>
+        <p:cNvGrpSpPr/>
+        <p:nvPr/>
+      </p:nvGrpSpPr>
+      <p:grpSpPr>
+        <a:xfrm>
+          <a:off x="0" y="0"/>
+          <a:ext cx="0" cy="0"/>
+          <a:chOff x="0" y="0"/>
+          <a:chExt cx="0" cy="0"/>
+        </a:xfrm>
+      </p:grpSpPr>
+      <p:sp>
+        <p:nvSpPr>
+          <p:cNvPr id="2" name="Shape 0"/>
+          <p:cNvSpPr/>
+          <p:nvPr/>
+        </p:nvSpPr>
+        <p:spPr>
+          <a:xfrm>
+            <a:off x="0" y="0"/>
+            <a:ext cx="4023360" cy="6858000"/>
+          </a:xfrm>
+          <a:prstGeom prst="rect">
+            <a:avLst/>
+          </a:prstGeom>
+          <a:solidFill>
+            <a:srgbClr val="024731"/>
+          </a:solidFill>
+          <a:ln/>
+        </p:spPr>
+        <p:txBody>
+          <a:bodyPr/>
+          <a:lstStyle/>
+          <a:p>
+            <a:endParaRPr lang="en-US"/>
+          </a:p>
+        </p:txBody>
+      </p:sp>
+      <p:sp>
+        <p:nvSpPr>
+          <p:cNvPr id="3" name="Shape 1"/>
+          <p:cNvSpPr/>
+          <p:nvPr/>
+        </p:nvSpPr>
+        <p:spPr>
+          <a:xfrm>
+            <a:off x="1271885" y="457200"/>
+            <a:ext cx="1479591" cy="2240280"/>
+          </a:xfrm>
+          <a:prstGeom prst="rect">
+            <a:avLst/>
+          </a:prstGeom>
+          <a:solidFill>
+            <a:srgbClr val="FFFFFF"/>
+          </a:solidFill>
+          <a:ln/>
+          <a:effectLst>
+            <a:outerShdw blurRad="114300" dist="38100" dir="8100000" algn="bl" rotWithShape="0">
+              <a:srgbClr val="000000">
+                <a:alpha val="28000"/>
+              </a:srgbClr>
+            </a:outerShdw>
+          </a:effectLst>
+        </p:spPr>
+        <p:txBody>
+          <a:bodyPr/>
+          <a:lstStyle/>
+          <a:p>
+            <a:endParaRPr lang="en-US"/>
+          </a:p>
+        </p:txBody>
+      </p:sp>
+      <p:pic>
+        <p:nvPicPr>
+          <p:cNvPr id="4" name="Image 0" descr="C:/GitHub/shidler/docs/presentations/assets/citrini-2028gic.jpg"/>
+          <p:cNvPicPr>
+            <a:picLocks noChangeAspect="1"/>
+          </p:cNvPicPr>
+          <p:nvPr/>
+        </p:nvPicPr>
+        <p:blipFill>
+          <a:blip r:embed="rId3"/>
+          <a:stretch>
+            <a:fillRect/>
+          </a:stretch>
+        </p:blipFill>
+        <p:spPr>
+          <a:xfrm>
+            <a:off x="1317605" y="502920"/>
+            <a:ext cx="1388151" cy="2148840"/>
+          </a:xfrm>
+          <a:prstGeom prst="rect">
+            <a:avLst/>
+          </a:prstGeom>
+        </p:spPr>
+      </p:pic>
+      <p:sp>
+        <p:nvSpPr>
+          <p:cNvPr id="5" name="Text 2"/>
+          <p:cNvSpPr/>
+          <p:nvPr/>
+        </p:nvSpPr>
+        <p:spPr>
+          <a:xfrm>
+            <a:off x="320040" y="2788920"/>
+            <a:ext cx="3383280" cy="292608"/>
+          </a:xfrm>
+          <a:prstGeom prst="rect">
+            <a:avLst/>
+          </a:prstGeom>
+          <a:noFill/>
+          <a:ln/>
+        </p:spPr>
+        <p:txBody>
+          <a:bodyPr wrap="square" lIns="0" tIns="0" rIns="0" bIns="0" rtlCol="0" anchor="ctr"/>
+          <a:lstStyle/>
+          <a:p>
+            <a:pPr marL="0" indent="0" algn="ctr">
+              <a:buNone/>
+            </a:pPr>
+            <a:r>
+              <a:rPr lang="en-US" sz="1200" b="1" kern="0" spc="150" dirty="0">
+                <a:solidFill>
+                  <a:srgbClr val="B3D9CF"/>
+                </a:solidFill>
+                <a:latin typeface="Open Sans" pitchFamily="34" charset="0"/>
+                <a:ea typeface="Open Sans" pitchFamily="34" charset="-122"/>
+                <a:cs typeface="Open Sans" pitchFamily="34" charset="-120"/>
+              </a:rPr>
+              <a:t>ECONOMICS &amp; AI</a:t>
+            </a:r>
+            <a:endParaRPr lang="en-US" sz="1200" dirty="0"/>
+          </a:p>
+        </p:txBody>
+      </p:sp>
+      <p:sp>
+        <p:nvSpPr>
+          <p:cNvPr id="6" name="Text 3"/>
+          <p:cNvSpPr/>
+          <p:nvPr/>
+        </p:nvSpPr>
+        <p:spPr>
+          <a:xfrm>
+            <a:off x="320040" y="3136392"/>
+            <a:ext cx="3383280" cy="1371600"/>
+          </a:xfrm>
+          <a:prstGeom prst="rect">
+            <a:avLst/>
+          </a:prstGeom>
+          <a:noFill/>
+          <a:ln/>
+        </p:spPr>
+        <p:txBody>
+          <a:bodyPr wrap="square" lIns="0" tIns="0" rIns="0" bIns="0" rtlCol="0" anchor="t"/>
+          <a:lstStyle/>
+          <a:p>
+            <a:pPr marL="0" indent="0" algn="ctr">
+              <a:lnSpc>
+                <a:spcPct val="98000"/>
+              </a:lnSpc>
+              <a:buNone/>
+            </a:pPr>
+            <a:r>
+              <a:rPr lang="en-US" sz="2100" b="1" dirty="0">
+                <a:solidFill>
+                  <a:srgbClr val="FFFFFF"/>
+                </a:solidFill>
+                <a:latin typeface="Open Sans" pitchFamily="34" charset="0"/>
+                <a:ea typeface="Open Sans" pitchFamily="34" charset="-122"/>
+                <a:cs typeface="Open Sans" pitchFamily="34" charset="-120"/>
+              </a:rPr>
+              <a:t>The 2028 Global Intelligence Crisis</a:t>
+            </a:r>
+            <a:endParaRPr lang="en-US" sz="2500" dirty="0"/>
+          </a:p>
+        </p:txBody>
+      </p:sp>
+      <p:sp>
+        <p:nvSpPr>
+          <p:cNvPr id="7" name="Text 4"/>
+          <p:cNvSpPr/>
+          <p:nvPr/>
+        </p:nvSpPr>
+        <p:spPr>
+          <a:xfrm>
+            <a:off x="320040" y="4343400"/>
+            <a:ext cx="3383280" cy="457200"/>
+          </a:xfrm>
+          <a:prstGeom prst="rect">
+            <a:avLst/>
+          </a:prstGeom>
+          <a:noFill/>
+          <a:ln/>
+        </p:spPr>
+        <p:txBody>
+          <a:bodyPr wrap="square" lIns="0" tIns="0" rIns="0" bIns="0" rtlCol="0" anchor="ctr"/>
+          <a:lstStyle/>
+          <a:p>
+            <a:pPr marL="0" indent="0" algn="ctr">
+              <a:buNone/>
+            </a:pPr>
+            <a:r>
+              <a:rPr lang="en-US" sz="1400" i="1" dirty="0">
+                <a:solidFill>
+                  <a:srgbClr val="B3D9CF"/>
+                </a:solidFill>
+                <a:latin typeface="Open Sans" pitchFamily="34" charset="0"/>
+                <a:ea typeface="Open Sans" pitchFamily="34" charset="-122"/>
+                <a:cs typeface="Open Sans" pitchFamily="34" charset="-120"/>
+              </a:rPr>
+              <a:t>Citrini &amp; Alap Shah</a:t>
+            </a:r>
+            <a:endParaRPr lang="en-US" sz="1400" dirty="0"/>
+          </a:p>
+        </p:txBody>
+      </p:sp>
+      <p:sp>
+        <p:nvSpPr>
+          <p:cNvPr id="8" name="Shape 5"/>
+          <p:cNvSpPr/>
+          <p:nvPr/>
+        </p:nvSpPr>
+        <p:spPr>
+          <a:xfrm>
+            <a:off x="914400" y="5897880"/>
+            <a:ext cx="2194560" cy="420624"/>
+          </a:xfrm>
+          <a:prstGeom prst="roundRect">
+            <a:avLst>
+              <a:gd name="adj" fmla="val 50000"/>
+            </a:avLst>
+          </a:prstGeom>
+          <a:solidFill>
+            <a:srgbClr val="012E1F"/>
+          </a:solidFill>
+          <a:ln/>
+        </p:spPr>
+        <p:txBody>
+          <a:bodyPr/>
+          <a:lstStyle/>
+          <a:p>
+            <a:endParaRPr lang="en-US"/>
+          </a:p>
+        </p:txBody>
+      </p:sp>
+      <p:sp>
+        <p:nvSpPr>
+          <p:cNvPr id="9" name="Text 6"/>
+          <p:cNvSpPr/>
+          <p:nvPr/>
+        </p:nvSpPr>
+        <p:spPr>
+          <a:xfrm>
+            <a:off x="914400" y="5897880"/>
+            <a:ext cx="2194560" cy="420624"/>
+          </a:xfrm>
+          <a:prstGeom prst="rect">
+            <a:avLst/>
+          </a:prstGeom>
+          <a:noFill/>
+          <a:ln/>
+        </p:spPr>
+        <p:txBody>
+          <a:bodyPr wrap="square" lIns="0" tIns="0" rIns="0" bIns="0" rtlCol="0" anchor="ctr"/>
+          <a:lstStyle/>
+          <a:p>
+            <a:pPr marL="0" indent="0" algn="ctr">
+              <a:buNone/>
+            </a:pPr>
+            <a:r>
+              <a:rPr lang="en-US" sz="1150" b="1" kern="0" spc="150" dirty="0">
+                <a:solidFill>
+                  <a:srgbClr val="FFFFFF"/>
+                </a:solidFill>
+                <a:latin typeface="Open Sans" pitchFamily="34" charset="0"/>
+                <a:ea typeface="Open Sans" pitchFamily="34" charset="-122"/>
+                <a:cs typeface="Open Sans" pitchFamily="34" charset="-120"/>
+              </a:rPr>
+              <a:t>ESSAY</a:t>
+            </a:r>
+            <a:endParaRPr lang="en-US" sz="1150" dirty="0"/>
+          </a:p>
+        </p:txBody>
+      </p:sp>
+      <p:sp>
+        <p:nvSpPr>
+          <p:cNvPr id="10" name="Text 7"/>
+          <p:cNvSpPr/>
+          <p:nvPr/>
+        </p:nvSpPr>
+        <p:spPr>
+          <a:xfrm>
+            <a:off x="4434840" y="640080"/>
+            <a:ext cx="7269480" cy="292608"/>
+          </a:xfrm>
+          <a:prstGeom prst="rect">
+            <a:avLst/>
+          </a:prstGeom>
+          <a:noFill/>
+          <a:ln/>
+        </p:spPr>
+        <p:txBody>
+          <a:bodyPr wrap="square" lIns="0" tIns="0" rIns="0" bIns="0" rtlCol="0" anchor="ctr"/>
+          <a:lstStyle/>
+          <a:p>
+            <a:pPr marL="0" indent="0">
+              <a:buNone/>
+            </a:pPr>
+            <a:r>
+              <a:rPr lang="en-US" sz="1300" b="1" kern="0" spc="100" dirty="0">
+                <a:solidFill>
+                  <a:srgbClr val="024731"/>
+                </a:solidFill>
+                <a:latin typeface="Open Sans" pitchFamily="34" charset="0"/>
+                <a:ea typeface="Open Sans" pitchFamily="34" charset="-122"/>
+                <a:cs typeface="Open Sans" pitchFamily="34" charset="-120"/>
+              </a:rPr>
+              <a:t>OVERVIEW</a:t>
+            </a:r>
+            <a:endParaRPr lang="en-US" sz="1300" dirty="0"/>
+          </a:p>
+        </p:txBody>
+      </p:sp>
+      <p:sp>
+        <p:nvSpPr>
+          <p:cNvPr id="11" name="Text 8"/>
+          <p:cNvSpPr/>
+          <p:nvPr/>
+        </p:nvSpPr>
+        <p:spPr>
+          <a:xfrm>
+            <a:off x="4434840" y="950976"/>
+            <a:ext cx="7269480" cy="1143000"/>
+          </a:xfrm>
+          <a:prstGeom prst="rect">
+            <a:avLst/>
+          </a:prstGeom>
+          <a:noFill/>
+          <a:ln/>
+        </p:spPr>
+        <p:txBody>
+          <a:bodyPr wrap="square" lIns="0" tIns="0" rIns="0" bIns="0" rtlCol="0" anchor="t"/>
+          <a:lstStyle/>
+          <a:p>
+            <a:pPr marL="0" indent="0">
+              <a:lnSpc>
+                <a:spcPct val="105000"/>
+              </a:lnSpc>
+              <a:buNone/>
+            </a:pPr>
+            <a:r>
+              <a:rPr lang="en-US" sz="1200" dirty="0">
+                <a:solidFill>
+                  <a:srgbClr val="1A1A1A"/>
+                </a:solidFill>
+                <a:latin typeface="Open Sans" pitchFamily="34" charset="0"/>
+                <a:ea typeface="Open Sans" pitchFamily="34" charset="-122"/>
+                <a:cs typeface="Open Sans" pitchFamily="34" charset="-120"/>
+              </a:rPr>
+              <a:t>A speculative “financial history, from the future”: Citrini and Alap Shah imagine how relentless AI progress could tip into an economic crisis by 2028. As capable AI gets cheaper, firms swap white-collar workers for agents, displaced spending falls, and the loop feeds on itself.</a:t>
+            </a:r>
+            <a:endParaRPr lang="en-US" sz="1200" dirty="0"/>
+          </a:p>
+        </p:txBody>
+      </p:sp>
+      <p:sp>
+        <p:nvSpPr>
+          <p:cNvPr id="12" name="Text 9"/>
+          <p:cNvSpPr/>
+          <p:nvPr/>
+        </p:nvSpPr>
+        <p:spPr>
+          <a:xfrm>
+            <a:off x="4434840" y="2212848"/>
+            <a:ext cx="7269480" cy="292608"/>
+          </a:xfrm>
+          <a:prstGeom prst="rect">
+            <a:avLst/>
+          </a:prstGeom>
+          <a:noFill/>
+          <a:ln/>
+        </p:spPr>
+        <p:txBody>
+          <a:bodyPr wrap="square" lIns="0" tIns="0" rIns="0" bIns="0" rtlCol="0" anchor="ctr"/>
+          <a:lstStyle/>
+          <a:p>
+            <a:pPr marL="0" indent="0">
+              <a:buNone/>
+            </a:pPr>
+            <a:r>
+              <a:rPr lang="en-US" sz="1300" b="1" kern="0" spc="100" dirty="0">
+                <a:solidFill>
+                  <a:srgbClr val="024731"/>
+                </a:solidFill>
+                <a:latin typeface="Open Sans" pitchFamily="34" charset="0"/>
+                <a:ea typeface="Open Sans" pitchFamily="34" charset="-122"/>
+                <a:cs typeface="Open Sans" pitchFamily="34" charset="-120"/>
+              </a:rPr>
+              <a:t>WHY IT MATTERS</a:t>
+            </a:r>
+            <a:endParaRPr lang="en-US" sz="1300" dirty="0"/>
+          </a:p>
+        </p:txBody>
+      </p:sp>
+      <p:sp>
+        <p:nvSpPr>
+          <p:cNvPr id="13" name="Text 10"/>
+          <p:cNvSpPr/>
+          <p:nvPr/>
+        </p:nvSpPr>
+        <p:spPr>
+          <a:xfrm>
+            <a:off x="4434840" y="2523744"/>
+            <a:ext cx="7269480" cy="1005840"/>
+          </a:xfrm>
+          <a:prstGeom prst="rect">
+            <a:avLst/>
+          </a:prstGeom>
+          <a:noFill/>
+          <a:ln/>
+        </p:spPr>
+        <p:txBody>
+          <a:bodyPr wrap="square" lIns="0" tIns="0" rIns="0" bIns="0" rtlCol="0" anchor="t"/>
+          <a:lstStyle/>
+          <a:p>
+            <a:pPr marL="0" indent="0">
+              <a:lnSpc>
+                <a:spcPct val="105000"/>
+              </a:lnSpc>
+              <a:buNone/>
+            </a:pPr>
+            <a:r>
+              <a:rPr lang="en-US" sz="1200" dirty="0">
+                <a:solidFill>
+                  <a:srgbClr val="1A1A1A"/>
+                </a:solidFill>
+                <a:latin typeface="Open Sans" pitchFamily="34" charset="0"/>
+                <a:ea typeface="Open Sans" pitchFamily="34" charset="-122"/>
+                <a:cs typeface="Open Sans" pitchFamily="34" charset="-120"/>
+              </a:rPr>
+              <a:t>Inverts the comforting “AI creates more jobs than it destroys” story by modeling AI as a substitute for labor — and traces how one shock could ripple through mortgages, private credit, and insurance. A disciplined way to reason about left-tail risk.</a:t>
+            </a:r>
+            <a:endParaRPr lang="en-US" sz="1200" dirty="0"/>
+          </a:p>
+        </p:txBody>
+      </p:sp>
+      <p:sp>
+        <p:nvSpPr>
+          <p:cNvPr id="14" name="Text 11"/>
+          <p:cNvSpPr/>
+          <p:nvPr/>
+        </p:nvSpPr>
+        <p:spPr>
+          <a:xfrm>
+            <a:off x="4434840" y="3657600"/>
+            <a:ext cx="7269480" cy="292608"/>
+          </a:xfrm>
+          <a:prstGeom prst="rect">
+            <a:avLst/>
+          </a:prstGeom>
+          <a:noFill/>
+          <a:ln/>
+        </p:spPr>
+        <p:txBody>
+          <a:bodyPr wrap="square" lIns="0" tIns="0" rIns="0" bIns="0" rtlCol="0" anchor="ctr"/>
+          <a:lstStyle/>
+          <a:p>
+            <a:pPr marL="0" indent="0">
+              <a:buNone/>
+            </a:pPr>
+            <a:r>
+              <a:rPr lang="en-US" sz="1300" b="1" kern="0" spc="100" dirty="0">
+                <a:solidFill>
+                  <a:srgbClr val="024731"/>
+                </a:solidFill>
+                <a:latin typeface="Open Sans" pitchFamily="34" charset="0"/>
+                <a:ea typeface="Open Sans" pitchFamily="34" charset="-122"/>
+                <a:cs typeface="Open Sans" pitchFamily="34" charset="-120"/>
+              </a:rPr>
+              <a:t>ABOUT THE AUTHOR</a:t>
+            </a:r>
+            <a:endParaRPr lang="en-US" sz="1300" dirty="0"/>
+          </a:p>
+        </p:txBody>
+      </p:sp>
+      <p:sp>
+        <p:nvSpPr>
+          <p:cNvPr id="15" name="Text 12"/>
+          <p:cNvSpPr/>
+          <p:nvPr/>
+        </p:nvSpPr>
+        <p:spPr>
+          <a:xfrm>
+            <a:off x="4434840" y="3968496"/>
+            <a:ext cx="7269480" cy="822960"/>
+          </a:xfrm>
+          <a:prstGeom prst="rect">
+            <a:avLst/>
+          </a:prstGeom>
+          <a:noFill/>
+          <a:ln/>
+        </p:spPr>
+        <p:txBody>
+          <a:bodyPr wrap="square" lIns="0" tIns="0" rIns="0" bIns="0" rtlCol="0" anchor="t"/>
+          <a:lstStyle/>
+          <a:p>
+            <a:pPr marL="0" indent="0">
+              <a:lnSpc>
+                <a:spcPct val="105000"/>
+              </a:lnSpc>
+              <a:buNone/>
+            </a:pPr>
+            <a:r>
+              <a:rPr lang="en-US" sz="1200" dirty="0">
+                <a:solidFill>
+                  <a:srgbClr val="555555"/>
+                </a:solidFill>
+                <a:latin typeface="Open Sans" pitchFamily="34" charset="0"/>
+                <a:ea typeface="Open Sans" pitchFamily="34" charset="-122"/>
+                <a:cs typeface="Open Sans" pitchFamily="34" charset="-120"/>
+              </a:rPr>
+              <a:t>Citrini Research is a widely-read thematic-investing publication on Substack; this scenario was co-authored with Alap Shah, a public-markets investor and founder of LOTUS Investment Management, Littlebird.ai, and Sentieo.</a:t>
+            </a:r>
+            <a:endParaRPr lang="en-US" sz="1200" dirty="0"/>
+          </a:p>
+        </p:txBody>
+      </p:sp>
+      <p:sp>
+        <p:nvSpPr>
+          <p:cNvPr id="16" name="Shape 13"/>
+          <p:cNvSpPr/>
+          <p:nvPr/>
+        </p:nvSpPr>
+        <p:spPr>
+          <a:xfrm>
+            <a:off x="4434840" y="4892040"/>
+            <a:ext cx="7269480" cy="1627632"/>
+          </a:xfrm>
+          <a:prstGeom prst="rect">
+            <a:avLst/>
+          </a:prstGeom>
+          <a:solidFill>
+            <a:srgbClr val="E6F2EF"/>
+          </a:solidFill>
+          <a:ln/>
+        </p:spPr>
+        <p:txBody>
+          <a:bodyPr/>
+          <a:lstStyle/>
+          <a:p>
+            <a:endParaRPr lang="en-US"/>
+          </a:p>
+        </p:txBody>
+      </p:sp>
+      <p:sp>
+        <p:nvSpPr>
+          <p:cNvPr id="17" name="Shape 14"/>
+          <p:cNvSpPr/>
+          <p:nvPr/>
+        </p:nvSpPr>
+        <p:spPr>
+          <a:xfrm>
+            <a:off x="4434840" y="4892040"/>
+            <a:ext cx="82296" cy="1627632"/>
+          </a:xfrm>
+          <a:prstGeom prst="rect">
+            <a:avLst/>
+          </a:prstGeom>
+          <a:solidFill>
+            <a:srgbClr val="024731"/>
+          </a:solidFill>
+          <a:ln/>
+        </p:spPr>
+        <p:txBody>
+          <a:bodyPr/>
+          <a:lstStyle/>
+          <a:p>
+            <a:endParaRPr lang="en-US"/>
+          </a:p>
+        </p:txBody>
+      </p:sp>
+      <p:sp>
+        <p:nvSpPr>
+          <p:cNvPr id="18" name="Shape 15"/>
+          <p:cNvSpPr/>
+          <p:nvPr/>
+        </p:nvSpPr>
+        <p:spPr>
+          <a:xfrm>
+            <a:off x="8069580" y="5120640"/>
+            <a:ext cx="0" cy="1170432"/>
+          </a:xfrm>
+          <a:prstGeom prst="line">
+            <a:avLst/>
+          </a:prstGeom>
+          <a:noFill/>
+          <a:ln w="12700">
+            <a:solidFill>
+              <a:srgbClr val="B3D9CF"/>
+            </a:solidFill>
+            <a:prstDash val="solid"/>
+          </a:ln>
+        </p:spPr>
+        <p:txBody>
+          <a:bodyPr/>
+          <a:lstStyle/>
+          <a:p>
+            <a:endParaRPr lang="en-US"/>
+          </a:p>
+        </p:txBody>
+      </p:sp>
+      <p:sp>
+        <p:nvSpPr>
+          <p:cNvPr id="19" name="Text 16"/>
+          <p:cNvSpPr/>
+          <p:nvPr/>
+        </p:nvSpPr>
+        <p:spPr>
+          <a:xfrm>
+            <a:off x="4709160" y="5093208"/>
+            <a:ext cx="3223260" cy="274320"/>
+          </a:xfrm>
+          <a:prstGeom prst="rect">
+            <a:avLst/>
+          </a:prstGeom>
+          <a:noFill/>
+          <a:ln/>
+        </p:spPr>
+        <p:txBody>
+          <a:bodyPr wrap="square" lIns="0" tIns="0" rIns="0" bIns="0" rtlCol="0" anchor="ctr"/>
+          <a:lstStyle/>
+          <a:p>
+            <a:pPr marL="0" indent="0">
+              <a:buNone/>
+            </a:pPr>
+            <a:r>
+              <a:rPr lang="en-US" sz="1100" b="1" kern="0" spc="150" dirty="0">
+                <a:solidFill>
+                  <a:srgbClr val="024731"/>
+                </a:solidFill>
+                <a:latin typeface="Open Sans" pitchFamily="34" charset="0"/>
+                <a:ea typeface="Open Sans" pitchFamily="34" charset="-122"/>
+                <a:cs typeface="Open Sans" pitchFamily="34" charset="-120"/>
+              </a:rPr>
+              <a:t>READ</a:t>
+            </a:r>
+            <a:endParaRPr lang="en-US" sz="1100" dirty="0"/>
+          </a:p>
+        </p:txBody>
+      </p:sp>
+      <p:sp>
+        <p:nvSpPr>
+          <p:cNvPr id="20" name="Text 17"/>
+          <p:cNvSpPr/>
+          <p:nvPr/>
+        </p:nvSpPr>
+        <p:spPr>
+          <a:xfrm>
+            <a:off x="4709160" y="5404104"/>
+            <a:ext cx="3223260" cy="941832"/>
+          </a:xfrm>
+          <a:prstGeom prst="rect">
+            <a:avLst/>
+          </a:prstGeom>
+          <a:noFill/>
+          <a:ln/>
+        </p:spPr>
+        <p:txBody>
+          <a:bodyPr wrap="square" lIns="0" tIns="0" rIns="0" bIns="0" rtlCol="0" anchor="t"/>
+          <a:lstStyle/>
+          <a:p>
+            <a:pPr marL="0" indent="0">
+              <a:lnSpc>
+                <a:spcPct val="115000"/>
+              </a:lnSpc>
+              <a:buNone/>
+            </a:pPr>
+            <a:r>
+              <a:rPr lang="en-US" sz="1100" b="1" dirty="0">
+                <a:solidFill>
+                  <a:srgbClr val="012E1F"/>
+                </a:solidFill>
+                <a:latin typeface="Open Sans" pitchFamily="34" charset="0"/>
+                <a:ea typeface="Open Sans" pitchFamily="34" charset="-122"/>
+                <a:cs typeface="Open Sans" pitchFamily="34" charset="-120"/>
+              </a:rPr>
+              <a:t>The 2028 Global Intelligence Crisis — Citrini Research (2026)</a:t>
+            </a:r>
+            <a:endParaRPr lang="en-US" sz="1100" dirty="0"/>
+          </a:p>
+        </p:txBody>
+      </p:sp>
+      <p:sp>
+        <p:nvSpPr>
+          <p:cNvPr id="21" name="Text 18"/>
+          <p:cNvSpPr/>
+          <p:nvPr/>
+        </p:nvSpPr>
+        <p:spPr>
+          <a:xfrm>
+            <a:off x="8161020" y="5093208"/>
+            <a:ext cx="3268980" cy="274320"/>
+          </a:xfrm>
+          <a:prstGeom prst="rect">
+            <a:avLst/>
+          </a:prstGeom>
+          <a:noFill/>
+          <a:ln/>
+        </p:spPr>
+        <p:txBody>
+          <a:bodyPr wrap="square" lIns="0" tIns="0" rIns="0" bIns="0" rtlCol="0" anchor="ctr"/>
+          <a:lstStyle/>
+          <a:p>
+            <a:pPr marL="0" indent="0">
+              <a:buNone/>
+            </a:pPr>
+            <a:r>
+              <a:rPr lang="en-US" sz="1100" b="1" kern="0" spc="150" dirty="0">
+                <a:solidFill>
+                  <a:srgbClr val="024731"/>
+                </a:solidFill>
+                <a:latin typeface="Open Sans" pitchFamily="34" charset="0"/>
+                <a:ea typeface="Open Sans" pitchFamily="34" charset="-122"/>
+                <a:cs typeface="Open Sans" pitchFamily="34" charset="-120"/>
+              </a:rPr>
+              <a:t>GO FURTHER</a:t>
+            </a:r>
+            <a:endParaRPr lang="en-US" sz="1100" dirty="0"/>
+          </a:p>
+        </p:txBody>
+      </p:sp>
+      <p:sp>
+        <p:nvSpPr>
+          <p:cNvPr id="22" name="Text 19"/>
+          <p:cNvSpPr/>
+          <p:nvPr/>
+        </p:nvSpPr>
+        <p:spPr>
+          <a:xfrm>
+            <a:off x="8161020" y="5404104"/>
+            <a:ext cx="3268980" cy="941832"/>
+          </a:xfrm>
+          <a:prstGeom prst="rect">
+            <a:avLst/>
+          </a:prstGeom>
+          <a:noFill/>
+          <a:ln/>
+        </p:spPr>
+        <p:txBody>
+          <a:bodyPr wrap="square" lIns="0" tIns="0" rIns="0" bIns="0" rtlCol="0" anchor="t"/>
+          <a:lstStyle/>
+          <a:p>
+            <a:pPr marL="342900" indent="-342900">
+              <a:lnSpc>
+                <a:spcPct val="110000"/>
+              </a:lnSpc>
+              <a:spcAft>
+                <a:spcPts val="300"/>
+              </a:spcAft>
+              <a:buSzPct val="100000"/>
+              <a:buChar char="•"/>
+            </a:pPr>
+            <a:r>
+              <a:rPr lang="en-US" sz="1100" dirty="0">
+                <a:solidFill>
+                  <a:srgbClr val="1A1A1A"/>
+                </a:solidFill>
+                <a:latin typeface="Open Sans" pitchFamily="34" charset="0"/>
+                <a:ea typeface="Open Sans" pitchFamily="34" charset="-122"/>
+                <a:cs typeface="Open Sans" pitchFamily="34" charset="-120"/>
+              </a:rPr>
+              <a:t>citriniresearch.com/p/2028gic</a:t>
+            </a:r>
+            <a:endParaRPr lang="en-US" sz="1100" dirty="0"/>
+          </a:p>
+          <a:p>
+            <a:pPr marL="342900" indent="-342900">
+              <a:lnSpc>
+                <a:spcPct val="110000"/>
+              </a:lnSpc>
+              <a:spcAft>
+                <a:spcPts val="300"/>
+              </a:spcAft>
+              <a:buSzPct val="100000"/>
+              <a:buChar char="•"/>
+            </a:pPr>
+            <a:r>
+              <a:rPr lang="en-US" sz="1100" dirty="0">
+                <a:solidFill>
+                  <a:srgbClr val="1A1A1A"/>
+                </a:solidFill>
+                <a:latin typeface="Open Sans" pitchFamily="34" charset="0"/>
+                <a:ea typeface="Open Sans" pitchFamily="34" charset="-122"/>
+                <a:cs typeface="Open Sans" pitchFamily="34" charset="-120"/>
+              </a:rPr>
+              <a:t>Pairs with Dalio's debt cycles &amp; The Everything Code</a:t>
+            </a:r>
+            <a:endParaRPr lang="en-US" sz="1100" dirty="0"/>
+          </a:p>
+        </p:txBody>
+      </p:sp>
+      <p:sp>
+        <p:nvSpPr>
+          <p:cNvPr id="23" name="Text 20"/>
+          <p:cNvSpPr/>
+          <p:nvPr/>
+        </p:nvSpPr>
+        <p:spPr>
+          <a:xfrm>
+            <a:off x="320040" y="6446520"/>
+            <a:ext cx="3383280" cy="274320"/>
+          </a:xfrm>
+          <a:prstGeom prst="rect">
+            <a:avLst/>
+          </a:prstGeom>
+          <a:noFill/>
+          <a:ln/>
+        </p:spPr>
+        <p:txBody>
+          <a:bodyPr wrap="square" lIns="0" tIns="0" rIns="0" bIns="0" rtlCol="0" anchor="ctr"/>
+          <a:lstStyle/>
+          <a:p>
+            <a:pPr marL="0" indent="0" algn="ctr">
+              <a:buNone/>
+            </a:pPr>
+            <a:r>
+              <a:rPr lang="en-US" sz="1000" dirty="0">
+                <a:solidFill>
+                  <a:srgbClr val="4DA78F"/>
+                </a:solidFill>
+                <a:latin typeface="Open Sans" pitchFamily="34" charset="0"/>
+                <a:ea typeface="Open Sans" pitchFamily="34" charset="-122"/>
+                <a:cs typeface="Open Sans" pitchFamily="34" charset="-120"/>
+              </a:rPr>
+              <a:t>9 / 9</a:t>
             </a:r>
             <a:endParaRPr lang="en-US" sz="1000" dirty="0"/>
           </a:p>
@@ -3054,7 +3917,7 @@
         </p:nvSpPr>
         <p:spPr>
           <a:xfrm>
-            <a:off x="825500" y="2006600"/>
+            <a:off x="825500" y="1850000"/>
             <a:ext cx="279400" cy="279400"/>
           </a:xfrm>
           <a:prstGeom prst="ellipse">
@@ -3096,8 +3959,8 @@
         </p:nvSpPr>
         <p:spPr>
           <a:xfrm>
-            <a:off x="1181100" y="1955800"/>
-            <a:ext cx="4914900" cy="1066800"/>
+            <a:off x="1181100" y="1799200"/>
+            <a:ext cx="4914900" cy="950000"/>
           </a:xfrm>
           <a:prstGeom prst="rect">
             <a:avLst/>
@@ -3161,7 +4024,7 @@
         </p:nvSpPr>
         <p:spPr>
           <a:xfrm>
-            <a:off x="6413500" y="2006600"/>
+            <a:off x="6413500" y="1850000"/>
             <a:ext cx="279400" cy="279400"/>
           </a:xfrm>
           <a:prstGeom prst="ellipse">
@@ -3203,8 +4066,8 @@
         </p:nvSpPr>
         <p:spPr>
           <a:xfrm>
-            <a:off x="6769100" y="1955800"/>
-            <a:ext cx="4914900" cy="1066800"/>
+            <a:off x="6769100" y="1799200"/>
+            <a:ext cx="4914900" cy="950000"/>
           </a:xfrm>
           <a:prstGeom prst="rect">
             <a:avLst/>
@@ -3268,7 +4131,7 @@
         </p:nvSpPr>
         <p:spPr>
           <a:xfrm>
-            <a:off x="825500" y="3124200"/>
+            <a:off x="825500" y="2830000"/>
             <a:ext cx="279400" cy="279400"/>
           </a:xfrm>
           <a:prstGeom prst="ellipse">
@@ -3310,8 +4173,8 @@
         </p:nvSpPr>
         <p:spPr>
           <a:xfrm>
-            <a:off x="1181100" y="3073400"/>
-            <a:ext cx="4914900" cy="1066800"/>
+            <a:off x="1181100" y="2779200"/>
+            <a:ext cx="4914900" cy="950000"/>
           </a:xfrm>
           <a:prstGeom prst="rect">
             <a:avLst/>
@@ -3375,7 +4238,7 @@
         </p:nvSpPr>
         <p:spPr>
           <a:xfrm>
-            <a:off x="6413500" y="3124200"/>
+            <a:off x="6413500" y="2830000"/>
             <a:ext cx="279400" cy="279400"/>
           </a:xfrm>
           <a:prstGeom prst="ellipse">
@@ -3417,8 +4280,8 @@
         </p:nvSpPr>
         <p:spPr>
           <a:xfrm>
-            <a:off x="6769100" y="3073400"/>
-            <a:ext cx="4914900" cy="1066800"/>
+            <a:off x="6769100" y="2779200"/>
+            <a:ext cx="4914900" cy="950000"/>
           </a:xfrm>
           <a:prstGeom prst="rect">
             <a:avLst/>
@@ -3482,7 +4345,7 @@
         </p:nvSpPr>
         <p:spPr>
           <a:xfrm>
-            <a:off x="825500" y="4241800"/>
+            <a:off x="825500" y="3810000"/>
             <a:ext cx="279400" cy="279400"/>
           </a:xfrm>
           <a:prstGeom prst="ellipse">
@@ -3524,8 +4387,8 @@
         </p:nvSpPr>
         <p:spPr>
           <a:xfrm>
-            <a:off x="1181100" y="4191000"/>
-            <a:ext cx="4914900" cy="1066800"/>
+            <a:off x="1181100" y="3759200"/>
+            <a:ext cx="4914900" cy="950000"/>
           </a:xfrm>
           <a:prstGeom prst="rect">
             <a:avLst/>
@@ -3589,7 +4452,7 @@
         </p:nvSpPr>
         <p:spPr>
           <a:xfrm>
-            <a:off x="6413500" y="4241800"/>
+            <a:off x="6413500" y="3810000"/>
             <a:ext cx="279400" cy="279400"/>
           </a:xfrm>
           <a:prstGeom prst="ellipse">
@@ -3631,8 +4494,8 @@
         </p:nvSpPr>
         <p:spPr>
           <a:xfrm>
-            <a:off x="6769100" y="4191000"/>
-            <a:ext cx="4914900" cy="1066800"/>
+            <a:off x="6769100" y="3759200"/>
+            <a:ext cx="4914900" cy="950000"/>
           </a:xfrm>
           <a:prstGeom prst="rect">
             <a:avLst/>
@@ -3696,7 +4559,7 @@
         </p:nvSpPr>
         <p:spPr>
           <a:xfrm>
-            <a:off x="825500" y="5359400"/>
+            <a:off x="825500" y="4790000"/>
             <a:ext cx="279400" cy="279400"/>
           </a:xfrm>
           <a:prstGeom prst="ellipse">
@@ -3738,8 +4601,8 @@
         </p:nvSpPr>
         <p:spPr>
           <a:xfrm>
-            <a:off x="1181100" y="5308600"/>
-            <a:ext cx="4914900" cy="1066800"/>
+            <a:off x="1181100" y="4739200"/>
+            <a:ext cx="4914900" cy="950000"/>
           </a:xfrm>
           <a:prstGeom prst="rect">
             <a:avLst/>
@@ -3803,7 +4666,7 @@
         </p:nvSpPr>
         <p:spPr>
           <a:xfrm>
-            <a:off x="6413500" y="5359400"/>
+            <a:off x="6413500" y="4790000"/>
             <a:ext cx="279400" cy="279400"/>
           </a:xfrm>
           <a:prstGeom prst="ellipse">
@@ -3845,8 +4708,8 @@
         </p:nvSpPr>
         <p:spPr>
           <a:xfrm>
-            <a:off x="6769100" y="5308600"/>
-            <a:ext cx="4914900" cy="1066800"/>
+            <a:off x="6769100" y="4739200"/>
+            <a:ext cx="4914900" cy="950000"/>
           </a:xfrm>
           <a:prstGeom prst="rect">
             <a:avLst/>
@@ -3896,6 +4759,113 @@
                 <a:latin typeface="Open Sans" pitchFamily="34" charset="0"/>
               </a:rPr>
               <a:t>A modern developer toolstack optimised for AI-assisted software development that is adaptable to business management</a:t>
+            </a:r>
+          </a:p>
+        </p:txBody>
+      </p:sp>
+      <p:sp>
+        <p:nvSpPr>
+          <p:cNvPr id="60" name="Badge 10"/>
+          <p:cNvSpPr>
+            <a:spLocks noGrp="1"/>
+          </p:cNvSpPr>
+          <p:nvPr/>
+        </p:nvSpPr>
+        <p:spPr>
+          <a:xfrm>
+            <a:off x="825500" y="5770000"/>
+            <a:ext cx="279400" cy="279400"/>
+          </a:xfrm>
+          <a:prstGeom prst="ellipse">
+            <a:avLst/>
+          </a:prstGeom>
+          <a:solidFill>
+            <a:srgbClr val="B3D9CF"/>
+          </a:solidFill>
+          <a:ln>
+            <a:noFill/>
+          </a:ln>
+        </p:spPr>
+        <p:txBody>
+          <a:bodyPr wrap="square" lIns="0" tIns="0" rIns="0" bIns="0" anchor="ctr"/>
+          <a:lstStyle/>
+          <a:p>
+            <a:pPr algn="ctr">
+              <a:buNone/>
+            </a:pPr>
+            <a:r>
+              <a:rPr lang="en-US" sz="1200" b="1" dirty="0">
+                <a:solidFill>
+                  <a:srgbClr val="1A2333"/>
+                </a:solidFill>
+                <a:latin typeface="Open Sans" pitchFamily="34" charset="0"/>
+              </a:rPr>
+              <a:t>10</a:t>
+            </a:r>
+          </a:p>
+        </p:txBody>
+      </p:sp>
+      <p:sp>
+        <p:nvSpPr>
+          <p:cNvPr id="61" name="Entry Text 10"/>
+          <p:cNvSpPr>
+            <a:spLocks noGrp="1"/>
+          </p:cNvSpPr>
+          <p:nvPr/>
+        </p:nvSpPr>
+        <p:spPr>
+          <a:xfrm>
+            <a:off x="1181100" y="5719200"/>
+            <a:ext cx="4914900" cy="950000"/>
+          </a:xfrm>
+          <a:prstGeom prst="rect">
+            <a:avLst/>
+          </a:prstGeom>
+          <a:noFill/>
+        </p:spPr>
+        <p:txBody>
+          <a:bodyPr wrap="square" lIns="0" tIns="0" rIns="0" bIns="0" anchor="t"/>
+          <a:lstStyle/>
+          <a:p>
+            <a:pPr marL="0" indent="0">
+              <a:buNone/>
+            </a:pPr>
+            <a:r>
+              <a:rPr lang="en-US" sz="1200" b="1" kern="0" spc="150" dirty="0">
+                <a:solidFill>
+                  <a:srgbClr val="B3D9CF"/>
+                </a:solidFill>
+                <a:latin typeface="Open Sans" pitchFamily="34" charset="0"/>
+              </a:rPr>
+              <a:t>ECONOMICS &amp; AI ESSAY</a:t>
+            </a:r>
+          </a:p>
+          <a:p>
+            <a:pPr marL="0" indent="0">
+              <a:buNone/>
+            </a:pPr>
+            <a:r>
+              <a:rPr lang="en-US" sz="1500" b="1" dirty="0">
+                <a:solidFill>
+                  <a:srgbClr val="FFFFFF"/>
+                </a:solidFill>
+                <a:latin typeface="Open Sans" pitchFamily="34" charset="0"/>
+              </a:rPr>
+              <a:t>The 2028 Global Intelligence Crisis</a:t>
+            </a:r>
+          </a:p>
+          <a:p>
+            <a:pPr marL="0" indent="0">
+              <a:buNone/>
+            </a:pPr>
+            <a:r>
+              <a:rPr lang="en-US" sz="1400" dirty="0">
+                <a:solidFill>
+                  <a:srgbClr val="A0B8C0"/>
+                </a:solidFill>
+                <a:latin typeface="Open Sans" pitchFamily="34" charset="0"/>
+              </a:rPr>
+              <a:t>A scenario in financial history from the future — how runaway AI could trigger a 2028 crisis</a:t>
             </a:r>
           </a:p>
         </p:txBody>
@@ -4761,7 +5731,7 @@
                 <a:ea typeface="Open Sans" pitchFamily="34" charset="-122"/>
                 <a:cs typeface="Open Sans" pitchFamily="34" charset="-120"/>
               </a:rPr>
-              <a:t>1 / 8</a:t>
+              <a:t>1 / 9</a:t>
             </a:r>
             <a:endParaRPr lang="en-US" sz="1000" dirty="0"/>
           </a:p>
@@ -5623,7 +6593,7 @@
                 <a:ea typeface="Open Sans" pitchFamily="34" charset="-122"/>
                 <a:cs typeface="Open Sans" pitchFamily="34" charset="-120"/>
               </a:rPr>
-              <a:t>2 / 8</a:t>
+              <a:t>2 / 9</a:t>
             </a:r>
             <a:endParaRPr lang="en-US" sz="1000" dirty="0"/>
           </a:p>
@@ -6562,7 +7532,7 @@
                 <a:ea typeface="Open Sans" pitchFamily="34" charset="-122"/>
                 <a:cs typeface="Open Sans" pitchFamily="34" charset="-120"/>
               </a:rPr>
-              <a:t>3 / 8</a:t>
+              <a:t>3 / 9</a:t>
             </a:r>
             <a:endParaRPr lang="en-US" sz="1000" dirty="0"/>
           </a:p>
@@ -7501,7 +8471,7 @@
                 <a:ea typeface="Open Sans" pitchFamily="34" charset="-122"/>
                 <a:cs typeface="Open Sans" pitchFamily="34" charset="-120"/>
               </a:rPr>
-              <a:t>4 / 8</a:t>
+              <a:t>4 / 9</a:t>
             </a:r>
             <a:endParaRPr lang="en-US" sz="1000" dirty="0"/>
           </a:p>
@@ -8440,7 +9410,7 @@
                 <a:ea typeface="Open Sans" pitchFamily="34" charset="-122"/>
                 <a:cs typeface="Open Sans" pitchFamily="34" charset="-120"/>
               </a:rPr>
-              <a:t>5 / 8</a:t>
+              <a:t>5 / 9</a:t>
             </a:r>
             <a:endParaRPr lang="en-US" sz="1000" dirty="0"/>
           </a:p>
@@ -9355,7 +10325,7 @@
                 <a:ea typeface="Open Sans" pitchFamily="34" charset="-122"/>
                 <a:cs typeface="Open Sans" pitchFamily="34" charset="-120"/>
               </a:rPr>
-              <a:t>6 / 8</a:t>
+              <a:t>6 / 9</a:t>
             </a:r>
             <a:endParaRPr lang="en-US" sz="1000" dirty="0"/>
           </a:p>
@@ -10217,7 +11187,7 @@
                 <a:ea typeface="Open Sans" pitchFamily="34" charset="-122"/>
                 <a:cs typeface="Open Sans" pitchFamily="34" charset="-120"/>
               </a:rPr>
-              <a:t>8 / 8</a:t>
+              <a:t>8 / 9</a:t>
             </a:r>
             <a:endParaRPr lang="en-US" sz="1000" dirty="0"/>
           </a:p>

</xml_diff>